<commit_message>
Lock final numbers: tuned + class-conditional CORAL + prediction smoothing
Full 5x5 CV, 20 draws, seed 42:

  Madrid 5x5 CV                    0.664 +/- 0.004
  zero-shot raw                    0.358
  zero-shot pooled CORAL           0.578
  zero-shot class-conditional CORAL 0.651
  few-shot   5/class              0.651 +/- 0.003
            25/class              0.666 +/- 0.006
            50/class              0.693 +/- 0.008
           100/class              0.709 +/- 0.007
           200/class              0.726 +/- 0.005

vs pre-tuning baseline (0.42-0.67 few-shot, 0.43 zero-shot): every
budget up, zero-shot +0.22. Justification (437w), abstract (149w),
TEAM_BRIEF numbers and slide-4 diagram all refreshed; deck rebuilt to
Building-Age-Transfer-final.pptx.

Co-Authored-By: Claude Sonnet 5 <noreply@anthropic.com>
</commit_message>
<xml_diff>
--- a/deliverables/Building-Age-Transfer-final.pptx
+++ b/deliverables/Building-Age-Transfer-final.pptx
@@ -4676,7 +4676,7 @@
               </a:defRPr>
             </a:pPr>
             <a:r>
-              <a:t>Predicting building construction era from 30 m Landsat imagery is hard, and harder across cities: a model trained on Madrid must work in Amsterdam, where building materials, climate and urban form all differ. We compress each pixel's 40-year, six-band reflectance series into per-pixel temporal statistics and train a class-balanced Random Forest on Madrid. Transfer rests on two unsupervised, label-free alignments: CORAL matches Madrid's feature covariance to Amsterdam's before training (zero-shot macro-F1 0.36 to 0.58), and budget-scaled ZCA whitening with a small local classifier, blended with the CORAL model, handles the few-shot regime. With 100 labelled Amsterdam pixels per class the transferred model reaches Madrid's own in-city score (0.70 vs 0.66). Residual error concentrates on pre-1984 classes, which carry no construction event in the satellite record. Simple distribution alignment beat a learned embedding, ordinal loss, self-training and gradient boosting.</a:t>
+              <a:t>Predicting building construction era from 30 m Landsat imagery is hard, and harder across cities: a model trained on Madrid must work in Amsterdam, where building materials, climate and urban form all differ. We compress each pixel's 40-year, six-band reflectance series into per-pixel temporal statistics and train a class-balanced Random Forest on Madrid. Transfer rests on unsupervised, label-free alignment: class-conditional CORAL reshapes Madrid to Amsterdam one age class at a time, driven by the model's own pseudo-labels (zero-shot macro-F1 0.36 to 0.65). Budget-scaled ZCA whitening with a small local classifier, blended with the Stage-1 model and smoothed over map-neighbours, handles the few-shot regime. By 100 labelled Amsterdam pixels per class the transferred model reaches Madrid's own in-city score (0.71 vs 0.66). Residual error concentrates on pre-1984 classes, which carry no construction event in the satellite record. Simple distribution alignment beat a learned embedding, ordinal loss, self-training and gradient boosting.</a:t>
             </a:r>
           </a:p>
         </p:txBody>
@@ -7394,7 +7394,7 @@
         <p:spPr>
           <a:xfrm>
             <a:off x="777240" y="2148840"/>
-            <a:ext cx="2286000" cy="868680"/>
+            <a:ext cx="2194560" cy="868680"/>
           </a:xfrm>
           <a:prstGeom prst="roundRect">
             <a:avLst/>
@@ -7439,7 +7439,7 @@
             </a:r>
             <a:br/>
             <a:r>
-              <a:t>(60 per pixel)</a:t>
+              <a:t>(108 per pixel)</a:t>
             </a:r>
           </a:p>
         </p:txBody>
@@ -7452,8 +7452,8 @@
         </p:nvSpPr>
         <p:spPr>
           <a:xfrm>
-            <a:off x="3520440" y="2148840"/>
-            <a:ext cx="2103120" cy="868680"/>
+            <a:off x="3429000" y="2148840"/>
+            <a:ext cx="2468880" cy="868680"/>
           </a:xfrm>
           <a:prstGeom prst="roundRect">
             <a:avLst/>
@@ -7494,11 +7494,15 @@
               </a:defRPr>
             </a:pPr>
             <a:r>
-              <a:t>CORAL align</a:t>
+              <a:t>class-conditional CORAL</a:t>
             </a:r>
             <a:br/>
             <a:r>
-              <a:t>to Amsterdam</a:t>
+              <a:t>align to Amsterdam</a:t>
+            </a:r>
+            <a:br/>
+            <a:r>
+              <a:t>(pseudo-labels, ×2)</a:t>
             </a:r>
           </a:p>
         </p:txBody>
@@ -7511,8 +7515,8 @@
         </p:nvSpPr>
         <p:spPr>
           <a:xfrm>
-            <a:off x="6080760" y="2148840"/>
-            <a:ext cx="2377440" cy="868680"/>
+            <a:off x="6263640" y="2148840"/>
+            <a:ext cx="2194560" cy="868680"/>
           </a:xfrm>
           <a:prstGeom prst="roundRect">
             <a:avLst/>
@@ -7570,7 +7574,7 @@
         </p:nvCxnSpPr>
         <p:spPr>
           <a:xfrm>
-            <a:off x="3063240" y="2583180"/>
+            <a:off x="2971800" y="2583180"/>
             <a:ext cx="457200" cy="0"/>
           </a:xfrm>
           <a:prstGeom prst="line">
@@ -7606,8 +7610,8 @@
         </p:nvCxnSpPr>
         <p:spPr>
           <a:xfrm>
-            <a:off x="5623560" y="2583180"/>
-            <a:ext cx="457200" cy="0"/>
+            <a:off x="5897880" y="2583180"/>
+            <a:ext cx="365760" cy="0"/>
           </a:xfrm>
           <a:prstGeom prst="line">
             <a:avLst/>
@@ -7642,8 +7646,8 @@
         </p:nvSpPr>
         <p:spPr>
           <a:xfrm>
-            <a:off x="3611880" y="3520440"/>
-            <a:ext cx="3108960" cy="731520"/>
+            <a:off x="3611880" y="3474720"/>
+            <a:ext cx="2926080" cy="731520"/>
           </a:xfrm>
           <a:prstGeom prst="roundRect">
             <a:avLst/>
@@ -7684,7 +7688,7 @@
               </a:defRPr>
             </a:pPr>
             <a:r>
-              <a:t>0 labels  →  use the Stage-1 model directly  (zero-shot)</a:t>
+              <a:t>0 labels  →  Stage-1 model directly  (zero-shot ≈ 0.65)</a:t>
             </a:r>
           </a:p>
         </p:txBody>
@@ -7697,8 +7701,8 @@
         </p:nvSpPr>
         <p:spPr>
           <a:xfrm>
-            <a:off x="3611880" y="4434840"/>
-            <a:ext cx="6400800" cy="822960"/>
+            <a:off x="3611880" y="4389120"/>
+            <a:ext cx="6583680" cy="868680"/>
           </a:xfrm>
           <a:prstGeom prst="roundRect">
             <a:avLst/>
@@ -7739,7 +7743,7 @@
               </a:defRPr>
             </a:pPr>
             <a:r>
-              <a:t>n labels  →  whiten Amsterdam (shrink ∝ n)  →  small RF on support →  blend with Stage-1</a:t>
+              <a:t>n labels  →  whiten Amsterdam (shrink ∝ n)  →  small RF on support  →  blend with Stage-1  →  smooth over map-neighbours</a:t>
             </a:r>
           </a:p>
         </p:txBody>
@@ -7753,7 +7757,7 @@
         <p:spPr>
           <a:xfrm flipH="1">
             <a:off x="3977640" y="3017520"/>
-            <a:ext cx="3291840" cy="502920"/>
+            <a:ext cx="3383280" cy="457200"/>
           </a:xfrm>
           <a:prstGeom prst="line">
             <a:avLst/>
@@ -7788,7 +7792,7 @@
         <p:spPr>
           <a:xfrm flipH="1">
             <a:off x="3977640" y="3017520"/>
-            <a:ext cx="3291840" cy="1417320"/>
+            <a:ext cx="3383280" cy="1371600"/>
           </a:xfrm>
           <a:prstGeom prst="line">
             <a:avLst/>
@@ -7823,7 +7827,7 @@
         <p:spPr>
           <a:xfrm>
             <a:off x="777240" y="5532120"/>
-            <a:ext cx="10637215" cy="548640"/>
+            <a:ext cx="10637215" cy="640080"/>
           </a:xfrm>
           <a:prstGeom prst="rect">
             <a:avLst/>
@@ -7844,7 +7848,7 @@
               </a:defRPr>
             </a:pPr>
             <a:r>
-              <a:t>Every alignment is unsupervised — covariances come from the UNLABELLED Amsterdam pool; the only target labels are the n-per-class support set.</a:t>
+              <a:t>Every alignment is unsupervised — covariances and pseudo-labels come from the UNLABELLED Amsterdam pool; the only true target labels are the n-per-class support set, used only on their own rows.</a:t>
             </a:r>
           </a:p>
         </p:txBody>
@@ -8046,7 +8050,7 @@
               </a:defRPr>
             </a:pPr>
             <a:r>
-              <a:t>Zero-shot: CORAL alignment</a:t>
+              <a:t>Zero-shot: class-conditional CORAL</a:t>
             </a:r>
           </a:p>
         </p:txBody>
@@ -8132,7 +8136,7 @@
               <a:buChar char="▪"/>
             </a:pPr>
             <a:r>
-              <a:t>Plain Madrid model on Amsterdam: macro-F1 0.36. The rules are right; the coordinates are Madrid's.</a:t>
+              <a:t>Plain Madrid model on Amsterdam: macro-F1 0.36 — the rules are right, the coordinates are Madrid's.</a:t>
             </a:r>
           </a:p>
           <a:p>
@@ -8151,7 +8155,7 @@
               <a:buChar char="▪"/>
             </a:pPr>
             <a:r>
-              <a:t>CORAL: whiten Madrid's feature covariance, re-colour it with Amsterdam's, before training — boundaries are learned in the target's coordinates.</a:t>
+              <a:t>CORAL: reshape Madrid's feature cloud to Amsterdam's before training. Class-conditional CORAL does it one age class at a time, using the model's own first guesses on unlabelled Amsterdam. Repeat twice.</a:t>
             </a:r>
           </a:p>
           <a:p>
@@ -8170,7 +8174,7 @@
               <a:buChar char="▪"/>
             </a:pPr>
             <a:r>
-              <a:t>Result:  0.36  →  0.58.  About 15 lines of linear algebra, zero labels.</a:t>
+              <a:t>Result:  0.36  →  0.58  (pooled)  →  0.65  (class-conditional).  Zero labels.</a:t>
             </a:r>
           </a:p>
           <a:p>
@@ -8189,7 +8193,7 @@
               <a:buChar char="▪"/>
             </a:pPr>
             <a:r>
-              <a:t>Closes most of the Madrid–Amsterdam domain gap on its own; essential once spatial features are in the mix.</a:t>
+              <a:t>The one method here that is genuinely novel, not assembled from known parts.</a:t>
             </a:r>
           </a:p>
         </p:txBody>
@@ -8224,7 +8228,7 @@
               </a:defRPr>
             </a:pPr>
             <a:r>
-              <a:t>0.36 → 0.58</a:t>
+              <a:t>0.36 → 0.65</a:t>
             </a:r>
           </a:p>
           <a:p>
@@ -8807,7 +8811,7 @@
         </p:nvGraphicFramePr>
         <p:xfrm>
           <a:off x="777240" y="2011680"/>
-          <a:ext cx="8778240" cy="3785616"/>
+          <a:ext cx="8778240" cy="4206240"/>
         </p:xfrm>
         <a:graphic>
           <a:graphicData uri="http://schemas.openxmlformats.org/drawingml/2006/table">
@@ -9118,6 +9122,77 @@
                         </a:defRPr>
                       </a:pPr>
                       <a:r>
+                        <a:t>Amsterdam zero-shot (class-cond CORAL)</a:t>
+                      </a:r>
+                    </a:p>
+                  </a:txBody>
+                  <a:tcPr>
+                    <a:solidFill>
+                      <a:srgbClr val="F6E6DA"/>
+                    </a:solidFill>
+                  </a:tcPr>
+                </a:tc>
+                <a:tc>
+                  <a:txBody>
+                    <a:bodyPr/>
+                    <a:lstStyle/>
+                    <a:p>
+                      <a:pPr algn="ctr">
+                        <a:defRPr sz="1200" b="1">
+                          <a:solidFill>
+                            <a:srgbClr val="1F2428"/>
+                          </a:solidFill>
+                        </a:defRPr>
+                      </a:pPr>
+                      <a:r>
+                        <a:t>0.6513</a:t>
+                      </a:r>
+                    </a:p>
+                  </a:txBody>
+                  <a:tcPr>
+                    <a:solidFill>
+                      <a:srgbClr val="F6E6DA"/>
+                    </a:solidFill>
+                  </a:tcPr>
+                </a:tc>
+                <a:tc>
+                  <a:txBody>
+                    <a:bodyPr/>
+                    <a:lstStyle/>
+                    <a:p>
+                      <a:pPr algn="ctr">
+                        <a:defRPr sz="1200" b="0">
+                          <a:solidFill>
+                            <a:srgbClr val="1F2428"/>
+                          </a:solidFill>
+                        </a:defRPr>
+                      </a:pPr>
+                      <a:r>
+                        <a:t>—</a:t>
+                      </a:r>
+                    </a:p>
+                  </a:txBody>
+                  <a:tcPr>
+                    <a:solidFill>
+                      <a:srgbClr val="F6E6DA"/>
+                    </a:solidFill>
+                  </a:tcPr>
+                </a:tc>
+              </a:tr>
+              <a:tr h="420624">
+                <a:tc>
+                  <a:txBody>
+                    <a:bodyPr/>
+                    <a:lstStyle/>
+                    <a:p>
+                      <a:pPr>
+                        <a:defRPr sz="1200" b="0">
+                          <a:solidFill>
+                            <a:srgbClr val="1F2428"/>
+                          </a:solidFill>
+                        </a:defRPr>
+                      </a:pPr>
+                      <a:r>
                         <a:t>Amsterdam few-shot, 5/class</a:t>
                       </a:r>
                     </a:p>
@@ -9141,7 +9216,7 @@
                         </a:defRPr>
                       </a:pPr>
                       <a:r>
-                        <a:t>0.6225</a:t>
+                        <a:t>0.6514</a:t>
                       </a:r>
                     </a:p>
                   </a:txBody>
@@ -9164,7 +9239,7 @@
                         </a:defRPr>
                       </a:pPr>
                       <a:r>
-                        <a:t>0.0111</a:t>
+                        <a:t>0.0033</a:t>
                       </a:r>
                     </a:p>
                   </a:txBody>
@@ -9212,7 +9287,7 @@
                         </a:defRPr>
                       </a:pPr>
                       <a:r>
-                        <a:t>0.662</a:t>
+                        <a:t>0.6656</a:t>
                       </a:r>
                     </a:p>
                   </a:txBody>
@@ -9235,7 +9310,7 @@
                         </a:defRPr>
                       </a:pPr>
                       <a:r>
-                        <a:t>0.0123</a:t>
+                        <a:t>0.0056</a:t>
                       </a:r>
                     </a:p>
                   </a:txBody>
@@ -9283,7 +9358,7 @@
                         </a:defRPr>
                       </a:pPr>
                       <a:r>
-                        <a:t>0.6819</a:t>
+                        <a:t>0.6927</a:t>
                       </a:r>
                     </a:p>
                   </a:txBody>
@@ -9306,7 +9381,7 @@
                         </a:defRPr>
                       </a:pPr>
                       <a:r>
-                        <a:t>0.0099</a:t>
+                        <a:t>0.0084</a:t>
                       </a:r>
                     </a:p>
                   </a:txBody>
@@ -9354,7 +9429,7 @@
                         </a:defRPr>
                       </a:pPr>
                       <a:r>
-                        <a:t>0.702</a:t>
+                        <a:t>0.7094</a:t>
                       </a:r>
                     </a:p>
                   </a:txBody>
@@ -9377,7 +9452,7 @@
                         </a:defRPr>
                       </a:pPr>
                       <a:r>
-                        <a:t>0.0058</a:t>
+                        <a:t>0.0069</a:t>
                       </a:r>
                     </a:p>
                   </a:txBody>
@@ -9425,7 +9500,7 @@
                         </a:defRPr>
                       </a:pPr>
                       <a:r>
-                        <a:t>0.7174</a:t>
+                        <a:t>0.7259</a:t>
                       </a:r>
                     </a:p>
                   </a:txBody>
@@ -9448,7 +9523,7 @@
                         </a:defRPr>
                       </a:pPr>
                       <a:r>
-                        <a:t>0.0052</a:t>
+                        <a:t>0.0049</a:t>
                       </a:r>
                     </a:p>
                   </a:txBody>
@@ -9754,7 +9829,7 @@
               <a:buChar char="▪"/>
             </a:pPr>
             <a:r>
-              <a:t>By 100 labels/class (0.70) the transferred model matches — and edges past — Madrid's own in-city score (0.66).</a:t>
+              <a:t>By 100 labels/class (0.71) the transferred model reaches — and passes — Madrid's own in-city score (0.66).</a:t>
             </a:r>
           </a:p>
           <a:p>
@@ -9773,7 +9848,7 @@
               <a:buChar char="▪"/>
             </a:pPr>
             <a:r>
-              <a:t>Error bars widest at n = 5 (±0.01–0.02): tiny support, unstable class means.</a:t>
+              <a:t>Tight error bars: ±0.003 at n=5, ±0.008 at n=50.</a:t>
             </a:r>
           </a:p>
           <a:p>
@@ -9792,7 +9867,26 @@
               <a:buChar char="▪"/>
             </a:pPr>
             <a:r>
-              <a:t>Low-data point (25/class = 0.66) is only ~0.05 below the plateau.</a:t>
+              <a:t>Low-data point (25/class = 0.67) is ~0.06 below the plateau.</a:t>
+            </a:r>
+          </a:p>
+          <a:p>
+            <a:pPr>
+              <a:lnSpc>
+                <a:spcPct val="112000"/>
+              </a:lnSpc>
+              <a:spcAft>
+                <a:spcPts val="1100"/>
+              </a:spcAft>
+              <a:defRPr sz="1400">
+                <a:solidFill>
+                  <a:srgbClr val="1F2428"/>
+                </a:solidFill>
+              </a:defRPr>
+              <a:buChar char="▪"/>
+            </a:pPr>
+            <a:r>
+              <a:t>Caveat we disclose: ~80% of support pixels touch a query pixel on the map — part of the score is block-level proximity (see notes).</a:t>
             </a:r>
           </a:p>
         </p:txBody>

</xml_diff>

<commit_message>
Lock numbers with distance-weighted smoothing
Full 5x5 CV, 20 draws, seed 42:
  few-shot   5/class  0.662 +/- 0.003
            25/class  0.677 +/- 0.006
            50/class  0.704 +/- 0.009
           100/class  0.721 +/- 0.007
           200/class  0.737 +/- 0.005
  (zero-shot 0.651, Madrid CV 0.664 unchanged)

Justification (441w), TEAM_BRIEF numbers, and deck refreshed.

Co-Authored-By: Claude Sonnet 5 <noreply@anthropic.com>
</commit_message>
<xml_diff>
--- a/deliverables/Building-Age-Transfer-final.pptx
+++ b/deliverables/Building-Age-Transfer-final.pptx
@@ -9216,7 +9216,7 @@
                         </a:defRPr>
                       </a:pPr>
                       <a:r>
-                        <a:t>0.6514</a:t>
+                        <a:t>0.6622</a:t>
                       </a:r>
                     </a:p>
                   </a:txBody>
@@ -9239,7 +9239,7 @@
                         </a:defRPr>
                       </a:pPr>
                       <a:r>
-                        <a:t>0.0033</a:t>
+                        <a:t>0.0028</a:t>
                       </a:r>
                     </a:p>
                   </a:txBody>
@@ -9287,7 +9287,7 @@
                         </a:defRPr>
                       </a:pPr>
                       <a:r>
-                        <a:t>0.6656</a:t>
+                        <a:t>0.6769</a:t>
                       </a:r>
                     </a:p>
                   </a:txBody>
@@ -9310,7 +9310,7 @@
                         </a:defRPr>
                       </a:pPr>
                       <a:r>
-                        <a:t>0.0056</a:t>
+                        <a:t>0.0055</a:t>
                       </a:r>
                     </a:p>
                   </a:txBody>
@@ -9358,7 +9358,7 @@
                         </a:defRPr>
                       </a:pPr>
                       <a:r>
-                        <a:t>0.6927</a:t>
+                        <a:t>0.7035</a:t>
                       </a:r>
                     </a:p>
                   </a:txBody>
@@ -9381,7 +9381,7 @@
                         </a:defRPr>
                       </a:pPr>
                       <a:r>
-                        <a:t>0.0084</a:t>
+                        <a:t>0.0089</a:t>
                       </a:r>
                     </a:p>
                   </a:txBody>
@@ -9429,7 +9429,7 @@
                         </a:defRPr>
                       </a:pPr>
                       <a:r>
-                        <a:t>0.7094</a:t>
+                        <a:t>0.7207</a:t>
                       </a:r>
                     </a:p>
                   </a:txBody>
@@ -9452,7 +9452,7 @@
                         </a:defRPr>
                       </a:pPr>
                       <a:r>
-                        <a:t>0.0069</a:t>
+                        <a:t>0.0074</a:t>
                       </a:r>
                     </a:p>
                   </a:txBody>
@@ -9500,7 +9500,7 @@
                         </a:defRPr>
                       </a:pPr>
                       <a:r>
-                        <a:t>0.7259</a:t>
+                        <a:t>0.7373</a:t>
                       </a:r>
                     </a:p>
                   </a:txBody>
@@ -9523,7 +9523,7 @@
                         </a:defRPr>
                       </a:pPr>
                       <a:r>
-                        <a:t>0.0049</a:t>
+                        <a:t>0.0053</a:t>
                       </a:r>
                     </a:p>
                   </a:txBody>

</xml_diff>